<commit_message>
sd-02-028, sd-02-032: fix WAR expansion, stage-2 summary, and the tech-stack quiz path
WAR is Web ARchive. The sd-02-028 summary now names stage 2 as the exception
to calling one place. sd-02-032 no longer presents the tool list as a request
path: lesson, figure (parts instead of steps) and deck slides 1, 3, 4, 5, 8
describe groups of the source's areas; PPTX re-exported for both decks.

Co-Authored-By: Claude Opus 5.5 <noreply@anthropic.com>
Claude-Session: https://claude.ai/code/session_01McBLtMnJbTnB94NeVs8a2V
</commit_message>
<xml_diff>
--- a/system-design-101/vi/lessons/sd-02-028/slides/sd-02-028.pptx
+++ b/system-design-101/vi/lessons/sd-02-028/slides/sd-02-028.pptx
@@ -3486,7 +3486,7 @@
                         <a:t>Web</a:t>
                       </a:r>
                       <a:r>
-                        <a:rPr lang="en-US" sz="2250" dirty="0" spc="-4" kern="0">
+                        <a:rPr lang="en-US" sz="2250" dirty="0" spc="-19" kern="0">
                           <a:solidFill>
                             <a:srgbClr val="E4E1D8"/>
                           </a:solidFill>
@@ -3494,18 +3494,7 @@
                           <a:ea typeface="Be Vietnam Pro" pitchFamily="34" charset="-122"/>
                           <a:cs typeface="Be Vietnam Pro" pitchFamily="34" charset="-120"/>
                         </a:rPr>
-                        <a:t> Application</a:t>
-                      </a:r>
-                      <a:r>
-                        <a:rPr lang="en-US" sz="2250" dirty="0" spc="-24" kern="0">
-                          <a:solidFill>
-                            <a:srgbClr val="E4E1D8"/>
-                          </a:solidFill>
-                          <a:latin typeface="Be Vietnam Pro" pitchFamily="34" charset="0"/>
-                          <a:ea typeface="Be Vietnam Pro" pitchFamily="34" charset="-122"/>
-                          <a:cs typeface="Be Vietnam Pro" pitchFamily="34" charset="-120"/>
-                        </a:rPr>
-                        <a:t> Resource</a:t>
+                        <a:t> ARchive</a:t>
                       </a:r>
                       <a:endParaRPr lang="en-US" sz="1200" dirty="0"/>
                     </a:p>
@@ -3563,6 +3552,39 @@
                         <a:t>tệp</a:t>
                       </a:r>
                       <a:r>
+                        <a:rPr lang="en-US" sz="2250" dirty="0" spc="17" kern="0">
+                          <a:solidFill>
+                            <a:srgbClr val="E4E1D8"/>
+                          </a:solidFill>
+                          <a:latin typeface="Be Vietnam Pro" pitchFamily="34" charset="0"/>
+                          <a:ea typeface="Be Vietnam Pro" pitchFamily="34" charset="-122"/>
+                          <a:cs typeface="Be Vietnam Pro" pitchFamily="34" charset="-120"/>
+                        </a:rPr>
+                        <a:t> lưu</a:t>
+                      </a:r>
+                      <a:r>
+                        <a:rPr lang="en-US" sz="2250" dirty="0" spc="1" kern="0">
+                          <a:solidFill>
+                            <a:srgbClr val="E4E1D8"/>
+                          </a:solidFill>
+                          <a:latin typeface="Be Vietnam Pro" pitchFamily="34" charset="0"/>
+                          <a:ea typeface="Be Vietnam Pro" pitchFamily="34" charset="-122"/>
+                          <a:cs typeface="Be Vietnam Pro" pitchFamily="34" charset="-120"/>
+                        </a:rPr>
+                        <a:t> trữ</a:t>
+                      </a:r>
+                      <a:r>
+                        <a:rPr lang="en-US" sz="2250" dirty="0" spc="-8" kern="0">
+                          <a:solidFill>
+                            <a:srgbClr val="E4E1D8"/>
+                          </a:solidFill>
+                          <a:latin typeface="Be Vietnam Pro" pitchFamily="34" charset="0"/>
+                          <a:ea typeface="Be Vietnam Pro" pitchFamily="34" charset="-122"/>
+                          <a:cs typeface="Be Vietnam Pro" pitchFamily="34" charset="-120"/>
+                        </a:rPr>
+                        <a:t> web:</a:t>
+                      </a:r>
+                      <a:r>
                         <a:rPr lang="en-US" sz="2250" dirty="0" spc="11" kern="0">
                           <a:solidFill>
                             <a:srgbClr val="E4E1D8"/>
@@ -3585,7 +3607,7 @@
                         <a:t> gói</a:t>
                       </a:r>
                       <a:r>
-                        <a:rPr lang="en-US" sz="2250" dirty="0" spc="24" kern="0">
+                        <a:rPr lang="en-US" sz="2250" dirty="0" spc="25" kern="0">
                           <a:solidFill>
                             <a:srgbClr val="E4E1D8"/>
                           </a:solidFill>
@@ -3596,7 +3618,7 @@
                         <a:t> ứng</a:t>
                       </a:r>
                       <a:r>
-                        <a:rPr lang="en-US" sz="2250" dirty="0" spc="3" kern="0">
+                        <a:rPr lang="en-US" sz="2250" dirty="0" spc="2" kern="0">
                           <a:solidFill>
                             <a:srgbClr val="E4E1D8"/>
                           </a:solidFill>
@@ -3607,18 +3629,7 @@
                         <a:t> dụng</a:t>
                       </a:r>
                       <a:r>
-                        <a:rPr lang="en-US" sz="2250" dirty="0" spc="-11" kern="0">
-                          <a:solidFill>
-                            <a:srgbClr val="E4E1D8"/>
-                          </a:solidFill>
-                          <a:latin typeface="Be Vietnam Pro" pitchFamily="34" charset="0"/>
-                          <a:ea typeface="Be Vietnam Pro" pitchFamily="34" charset="-122"/>
-                          <a:cs typeface="Be Vietnam Pro" pitchFamily="34" charset="-120"/>
-                        </a:rPr>
-                        <a:t> web</a:t>
-                      </a:r>
-                      <a:r>
-                        <a:rPr lang="en-US" sz="2250" dirty="0" spc="-21" kern="0">
+                        <a:rPr lang="en-US" sz="2250" dirty="0" spc="-20" kern="0">
                           <a:solidFill>
                             <a:srgbClr val="E4E1D8"/>
                           </a:solidFill>

</xml_diff>

<commit_message>
sd-02-028: old clients break only when an address or response they depend on changes
Co-Authored-By: Claude Opus 5.5 <noreply@anthropic.com>
Claude-Session: https://claude.ai/code/session_01McBLtMnJbTnB94NeVs8a2V
</commit_message>
<xml_diff>
--- a/system-design-101/vi/lessons/sd-02-028/slides/sd-02-028.pptx
+++ b/system-design-101/vi/lessons/sd-02-028/slides/sd-02-028.pptx
@@ -13571,7 +13571,7 @@
               <a:buNone/>
             </a:pPr>
             <a:r>
-              <a:rPr lang="en-US" sz="2850" b="1" dirty="0" spc="-3" kern="0">
+              <a:rPr lang="en-US" sz="2850" b="1" dirty="0" spc="1" kern="0">
                 <a:solidFill>
                   <a:srgbClr val="F3EEE3"/>
                 </a:solidFill>
@@ -13579,7 +13579,95 @@
                 <a:ea typeface="Be Vietnam Pro" pitchFamily="34" charset="-122"/>
                 <a:cs typeface="Be Vietnam Pro" pitchFamily="34" charset="-120"/>
               </a:rPr>
-              <a:t>Ứng</a:t>
+              <a:t>Đổi</a:t>
+            </a:r>
+            <a:r>
+              <a:rPr lang="en-US" sz="2850" b="1" dirty="0" spc="21" kern="0">
+                <a:solidFill>
+                  <a:srgbClr val="F3EEE3"/>
+                </a:solidFill>
+                <a:latin typeface="Be Vietnam Pro" pitchFamily="34" charset="0"/>
+                <a:ea typeface="Be Vietnam Pro" pitchFamily="34" charset="-122"/>
+                <a:cs typeface="Be Vietnam Pro" pitchFamily="34" charset="-120"/>
+              </a:rPr>
+              <a:t> địa</a:t>
+            </a:r>
+            <a:r>
+              <a:rPr lang="en-US" sz="2850" b="1" dirty="0" spc="1" kern="0">
+                <a:solidFill>
+                  <a:srgbClr val="F3EEE3"/>
+                </a:solidFill>
+                <a:latin typeface="Be Vietnam Pro" pitchFamily="34" charset="0"/>
+                <a:ea typeface="Be Vietnam Pro" pitchFamily="34" charset="-122"/>
+                <a:cs typeface="Be Vietnam Pro" pitchFamily="34" charset="-120"/>
+              </a:rPr>
+              <a:t> chỉ</a:t>
+            </a:r>
+            <a:r>
+              <a:rPr lang="en-US" sz="2850" b="1" dirty="0" spc="-12" kern="0">
+                <a:solidFill>
+                  <a:srgbClr val="F3EEE3"/>
+                </a:solidFill>
+                <a:latin typeface="Be Vietnam Pro" pitchFamily="34" charset="0"/>
+                <a:ea typeface="Be Vietnam Pro" pitchFamily="34" charset="-122"/>
+                <a:cs typeface="Be Vietnam Pro" pitchFamily="34" charset="-120"/>
+              </a:rPr>
+              <a:t> hay</a:t>
+            </a:r>
+            <a:r>
+              <a:rPr lang="en-US" sz="2850" b="1" dirty="0" spc="2" kern="0">
+                <a:solidFill>
+                  <a:srgbClr val="F3EEE3"/>
+                </a:solidFill>
+                <a:latin typeface="Be Vietnam Pro" pitchFamily="34" charset="0"/>
+                <a:ea typeface="Be Vietnam Pro" pitchFamily="34" charset="-122"/>
+                <a:cs typeface="Be Vietnam Pro" pitchFamily="34" charset="-120"/>
+              </a:rPr>
+              <a:t> cách</a:t>
+            </a:r>
+            <a:r>
+              <a:rPr lang="en-US" sz="2850" b="1" dirty="0" spc="-14" kern="0">
+                <a:solidFill>
+                  <a:srgbClr val="F3EEE3"/>
+                </a:solidFill>
+                <a:latin typeface="Be Vietnam Pro" pitchFamily="34" charset="0"/>
+                <a:ea typeface="Be Vietnam Pro" pitchFamily="34" charset="-122"/>
+                <a:cs typeface="Be Vietnam Pro" pitchFamily="34" charset="-120"/>
+              </a:rPr>
+              <a:t> trả</a:t>
+            </a:r>
+            <a:r>
+              <a:rPr lang="en-US" sz="2850" b="1" dirty="0" spc="4" kern="0">
+                <a:solidFill>
+                  <a:srgbClr val="F3EEE3"/>
+                </a:solidFill>
+                <a:latin typeface="Be Vietnam Pro" pitchFamily="34" charset="0"/>
+                <a:ea typeface="Be Vietnam Pro" pitchFamily="34" charset="-122"/>
+                <a:cs typeface="Be Vietnam Pro" pitchFamily="34" charset="-120"/>
+              </a:rPr>
+              <a:t> lời:</a:t>
+            </a:r>
+            <a:r>
+              <a:rPr lang="en-US" sz="2850" b="1" dirty="0" spc="-9" kern="0">
+                <a:solidFill>
+                  <a:srgbClr val="F3EEE3"/>
+                </a:solidFill>
+                <a:latin typeface="Be Vietnam Pro" pitchFamily="34" charset="0"/>
+                <a:ea typeface="Be Vietnam Pro" pitchFamily="34" charset="-122"/>
+                <a:cs typeface="Be Vietnam Pro" pitchFamily="34" charset="-120"/>
+              </a:rPr>
+              <a:t> hỏng</a:t>
+            </a:r>
+            <a:r>
+              <a:rPr lang="en-US" sz="2850" b="1" dirty="0" spc="37" kern="0">
+                <a:solidFill>
+                  <a:srgbClr val="F3EEE3"/>
+                </a:solidFill>
+                <a:latin typeface="Be Vietnam Pro" pitchFamily="34" charset="0"/>
+                <a:ea typeface="Be Vietnam Pro" pitchFamily="34" charset="-122"/>
+                <a:cs typeface="Be Vietnam Pro" pitchFamily="34" charset="-120"/>
+              </a:rPr>
+              <a:t> ứng</a:t>
             </a:r>
             <a:r>
               <a:rPr lang="en-US" sz="2850" b="1" dirty="0" spc="0" kern="0">
@@ -13593,7 +13681,7 @@
               <a:t> dụng</a:t>
             </a:r>
             <a:r>
-              <a:rPr lang="en-US" sz="2850" b="1" dirty="0" spc="4" kern="0">
+              <a:rPr lang="en-US" sz="2850" b="1" dirty="0" spc="3" kern="0">
                 <a:solidFill>
                   <a:srgbClr val="F3EEE3"/>
                 </a:solidFill>
@@ -13602,50 +13690,6 @@
                 <a:cs typeface="Be Vietnam Pro" pitchFamily="34" charset="-120"/>
               </a:rPr>
               <a:t> cũ</a:t>
-            </a:r>
-            <a:r>
-              <a:rPr lang="en-US" sz="2850" b="1" dirty="0" spc="10" kern="0">
-                <a:solidFill>
-                  <a:srgbClr val="F3EEE3"/>
-                </a:solidFill>
-                <a:latin typeface="Be Vietnam Pro" pitchFamily="34" charset="0"/>
-                <a:ea typeface="Be Vietnam Pro" pitchFamily="34" charset="-122"/>
-                <a:cs typeface="Be Vietnam Pro" pitchFamily="34" charset="-120"/>
-              </a:rPr>
-              <a:t> đã</a:t>
-            </a:r>
-            <a:r>
-              <a:rPr lang="en-US" sz="2850" b="1" dirty="0" spc="2" kern="0">
-                <a:solidFill>
-                  <a:srgbClr val="F3EEE3"/>
-                </a:solidFill>
-                <a:latin typeface="Be Vietnam Pro" pitchFamily="34" charset="0"/>
-                <a:ea typeface="Be Vietnam Pro" pitchFamily="34" charset="-122"/>
-                <a:cs typeface="Be Vietnam Pro" pitchFamily="34" charset="-120"/>
-              </a:rPr>
-              <a:t> cài</a:t>
-            </a:r>
-            <a:r>
-              <a:rPr lang="en-US" sz="2850" b="1" dirty="0" spc="0" kern="0">
-                <a:solidFill>
-                  <a:srgbClr val="F3EEE3"/>
-                </a:solidFill>
-                <a:latin typeface="Be Vietnam Pro" pitchFamily="34" charset="0"/>
-                <a:ea typeface="Be Vietnam Pro" pitchFamily="34" charset="-122"/>
-                <a:cs typeface="Be Vietnam Pro" pitchFamily="34" charset="-120"/>
-              </a:rPr>
-              <a:t> sẽ</a:t>
-            </a:r>
-            <a:r>
-              <a:rPr lang="en-US" sz="2850" b="1" dirty="0" spc="-9" kern="0">
-                <a:solidFill>
-                  <a:srgbClr val="F3EEE3"/>
-                </a:solidFill>
-                <a:latin typeface="Be Vietnam Pro" pitchFamily="34" charset="0"/>
-                <a:ea typeface="Be Vietnam Pro" pitchFamily="34" charset="-122"/>
-                <a:cs typeface="Be Vietnam Pro" pitchFamily="34" charset="-120"/>
-              </a:rPr>
-              <a:t> hỏng</a:t>
             </a:r>
             <a:endParaRPr lang="en-US" sz="2850" dirty="0"/>
           </a:p>

</xml_diff>